<commit_message>
update tiktok sentimen analysis result - experiment
</commit_message>
<xml_diff>
--- a/tiktok-unsia-analysis-experiment/reports/report_tiktok-universitas-siber-asia.pptx
+++ b/tiktok-unsia-analysis-experiment/reports/report_tiktok-universitas-siber-asia.pptx
@@ -4359,7 +4359,7 @@
               </a:defRPr>
             </a:pPr>
             <a:r>
-              <a:t>• Berikut adalah laporan analisis data sentimen akun TikTok Universitas Siber Asia (UNSIA):</a:t>
+              <a:t>• Berikut adalah laporan analisis data sentimen untuk akun TikTok Universitas Siber Asia:</a:t>
             </a:r>
           </a:p>
           <a:p>
@@ -4391,7 +4391,7 @@
               </a:defRPr>
             </a:pPr>
             <a:r>
-              <a:t>• Dari total 4.925 komentar yang dianalisis, distribusi sentimen didominasi oleh kategori Netral (65,44%), diikuti oleh Positif (32,71%), dan Negatif (1,85%).</a:t>
+              <a:t>• Akun TikTok Universitas Siber Asia menerima total 4.925 komentar dengan distribusi sentimen sebagai berikut:</a:t>
             </a:r>
           </a:p>
           <a:p>
@@ -4407,7 +4407,7 @@
               </a:defRPr>
             </a:pPr>
             <a:r>
-              <a:t>• Netral: 3.223 komentar (1.974 likes, rata-rata 0,61 like/komentar).</a:t>
+              <a:t>• Netral: 3.223 komentar (65,44%)</a:t>
             </a:r>
           </a:p>
         </p:txBody>
@@ -5117,7 +5117,7 @@
         <p:spPr>
           <a:xfrm>
             <a:off x="548640" y="1371600"/>
-            <a:ext cx="3840480" cy="1280160"/>
+            <a:ext cx="3291840" cy="1280160"/>
           </a:xfrm>
           <a:prstGeom prst="roundRect">
             <a:avLst/>
@@ -5205,7 +5205,7 @@
         <p:spPr>
           <a:xfrm>
             <a:off x="804672" y="1463040"/>
-            <a:ext cx="3520440" cy="1097280"/>
+            <a:ext cx="2971800" cy="1097280"/>
           </a:xfrm>
           <a:prstGeom prst="rect">
             <a:avLst/>
@@ -5254,7 +5254,7 @@
         <p:spPr>
           <a:xfrm>
             <a:off x="548640" y="2971800"/>
-            <a:ext cx="3840480" cy="1280160"/>
+            <a:ext cx="3291840" cy="1280160"/>
           </a:xfrm>
           <a:prstGeom prst="roundRect">
             <a:avLst/>
@@ -5342,7 +5342,7 @@
         <p:spPr>
           <a:xfrm>
             <a:off x="804672" y="3063240"/>
-            <a:ext cx="3520440" cy="1097280"/>
+            <a:ext cx="2971800" cy="1097280"/>
           </a:xfrm>
           <a:prstGeom prst="rect">
             <a:avLst/>
@@ -5391,7 +5391,7 @@
         <p:spPr>
           <a:xfrm>
             <a:off x="548640" y="4572000"/>
-            <a:ext cx="3840480" cy="1280160"/>
+            <a:ext cx="3291840" cy="1280160"/>
           </a:xfrm>
           <a:prstGeom prst="roundRect">
             <a:avLst/>
@@ -5479,7 +5479,7 @@
         <p:spPr>
           <a:xfrm>
             <a:off x="804672" y="4663440"/>
-            <a:ext cx="3520440" cy="1097280"/>
+            <a:ext cx="2971800" cy="1097280"/>
           </a:xfrm>
           <a:prstGeom prst="rect">
             <a:avLst/>
@@ -5535,8 +5535,8 @@
         </p:blipFill>
         <p:spPr>
           <a:xfrm>
-            <a:off x="4754880" y="1280160"/>
-            <a:ext cx="6858000" cy="4389120"/>
+            <a:off x="4206240" y="1280160"/>
+            <a:ext cx="7498079" cy="4389120"/>
           </a:xfrm>
           <a:prstGeom prst="rect">
             <a:avLst/>

</xml_diff>